<commit_message>
Incremental Build at 2026-10-17 00:45:24
</commit_message>
<xml_diff>
--- a/Lectures/Slides/L2.pptx
+++ b/Lectures/Slides/L2.pptx
@@ -19280,8 +19280,10 @@
       <p:sp>
         <p:nvSpPr>
           <p:cNvPr id="82" name="Google Shape;82;p26"/>
-          <p:cNvSpPr txBox="1"/>
-          <p:nvPr/>
+          <p:cNvSpPr/>
+          <p:nvPr>
+            <p:ph type="title"/>
+          </p:nvPr>
         </p:nvSpPr>
         <p:spPr>
           <a:xfrm>
@@ -19355,14 +19357,18 @@
               <a:buNone/>
             </a:pPr>
             <a:r>
-              <a:rPr lang="en-US" sz="2500" dirty="0">
+              <a:rPr i="0" b="0" lang="en-US" sz="2500" dirty="0">
                 <a:solidFill>
                   <a:schemeClr val="lt1"/>
                 </a:solidFill>
               </a:rPr>
               <a:t>Lecture 2: Peripherals</a:t>
             </a:r>
-            <a:endParaRPr dirty="0"/>
+            <a:endParaRPr i="0" b="0" sz="1400" dirty="0">
+              <a:solidFill>
+                <a:srgbClr val="000000"/>
+              </a:solidFill>
+            </a:endParaRPr>
           </a:p>
           <a:p>
             <a:pPr marL="0" marR="0" lvl="0" indent="0" algn="ctr" rtl="0">
@@ -19401,7 +19407,7 @@
               <a:buNone/>
             </a:pPr>
             <a:r>
-              <a:rPr lang="en-US" sz="1800" dirty="0">
+              <a:rPr i="0" b="0" lang="en-US" sz="1800" dirty="0">
                 <a:solidFill>
                   <a:schemeClr val="lt1"/>
                 </a:solidFill>
@@ -19536,7 +19542,13 @@
       </p:sp>
       <p:pic>
         <p:nvPicPr>
-          <p:cNvPr id="84" name="Google Shape;84;p26"/>
+          <p:cNvPr id="84" name="Google Shape;84;p26">
+            <a:extLst>
+              <a:ext uri="{C183D7F6-B498-43B3-948B-1728B52AA6E4}">
+                <adec:decorative xmlns:adec="http://schemas.microsoft.com/office/drawing/2017/decorative" val="1"/>
+              </a:ext>
+            </a:extLst>
+          </p:cNvPr>
           <p:cNvPicPr preferRelativeResize="0"/>
           <p:nvPr/>
         </p:nvPicPr>
@@ -20066,8 +20078,10 @@
               </a:ext>
             </a:extLst>
           </p:cNvPr>
-          <p:cNvSpPr txBox="1"/>
-          <p:nvPr/>
+          <p:cNvSpPr/>
+          <p:nvPr>
+            <p:ph type="title"/>
+          </p:nvPr>
         </p:nvSpPr>
         <p:spPr>
           <a:xfrm>
@@ -20133,6 +20147,9 @@
         <p:nvPicPr>
           <p:cNvPr id="121" name="Google Shape;121;p29">
             <a:extLst>
+              <a:ext uri="{C183D7F6-B498-43B3-948B-1728B52AA6E4}">
+                <adec:decorative xmlns:adec="http://schemas.microsoft.com/office/drawing/2017/decorative" val="1"/>
+              </a:ext>
               <a:ext uri="{FF2B5EF4-FFF2-40B4-BE49-F238E27FC236}">
                 <a16:creationId xmlns:a16="http://schemas.microsoft.com/office/drawing/2014/main" id="{0FA08611-B304-CD35-D2C6-87BFF403FDD9}"/>
               </a:ext>
@@ -20836,8 +20853,10 @@
               </a:ext>
             </a:extLst>
           </p:cNvPr>
-          <p:cNvSpPr txBox="1"/>
-          <p:nvPr/>
+          <p:cNvSpPr/>
+          <p:nvPr>
+            <p:ph type="title"/>
+          </p:nvPr>
         </p:nvSpPr>
         <p:spPr>
           <a:xfrm>
@@ -20903,6 +20922,9 @@
         <p:nvPicPr>
           <p:cNvPr id="121" name="Google Shape;121;p29">
             <a:extLst>
+              <a:ext uri="{C183D7F6-B498-43B3-948B-1728B52AA6E4}">
+                <adec:decorative xmlns:adec="http://schemas.microsoft.com/office/drawing/2017/decorative" val="1"/>
+              </a:ext>
               <a:ext uri="{FF2B5EF4-FFF2-40B4-BE49-F238E27FC236}">
                 <a16:creationId xmlns:a16="http://schemas.microsoft.com/office/drawing/2014/main" id="{F68D369D-85E0-F5B0-1E38-6A002F63DE44}"/>
               </a:ext>
@@ -21655,8 +21677,10 @@
               </a:ext>
             </a:extLst>
           </p:cNvPr>
-          <p:cNvSpPr txBox="1"/>
-          <p:nvPr/>
+          <p:cNvSpPr/>
+          <p:nvPr>
+            <p:ph type="title"/>
+          </p:nvPr>
         </p:nvSpPr>
         <p:spPr>
           <a:xfrm>
@@ -21722,6 +21746,9 @@
         <p:nvPicPr>
           <p:cNvPr id="121" name="Google Shape;121;p29">
             <a:extLst>
+              <a:ext uri="{C183D7F6-B498-43B3-948B-1728B52AA6E4}">
+                <adec:decorative xmlns:adec="http://schemas.microsoft.com/office/drawing/2017/decorative" val="1"/>
+              </a:ext>
               <a:ext uri="{FF2B5EF4-FFF2-40B4-BE49-F238E27FC236}">
                 <a16:creationId xmlns:a16="http://schemas.microsoft.com/office/drawing/2014/main" id="{B2ECC981-9977-ED6B-5D97-285443D5C0EE}"/>
               </a:ext>
@@ -22649,8 +22676,10 @@
               </a:ext>
             </a:extLst>
           </p:cNvPr>
-          <p:cNvSpPr txBox="1"/>
-          <p:nvPr/>
+          <p:cNvSpPr/>
+          <p:nvPr>
+            <p:ph type="title"/>
+          </p:nvPr>
         </p:nvSpPr>
         <p:spPr>
           <a:xfrm>
@@ -22716,6 +22745,9 @@
         <p:nvPicPr>
           <p:cNvPr id="121" name="Google Shape;121;p29">
             <a:extLst>
+              <a:ext uri="{C183D7F6-B498-43B3-948B-1728B52AA6E4}">
+                <adec:decorative xmlns:adec="http://schemas.microsoft.com/office/drawing/2017/decorative" val="1"/>
+              </a:ext>
               <a:ext uri="{FF2B5EF4-FFF2-40B4-BE49-F238E27FC236}">
                 <a16:creationId xmlns:a16="http://schemas.microsoft.com/office/drawing/2014/main" id="{52A6F078-9316-17CF-4FBB-DDD54C30ED7F}"/>
               </a:ext>
@@ -23388,8 +23420,10 @@
               </a:ext>
             </a:extLst>
           </p:cNvPr>
-          <p:cNvSpPr txBox="1"/>
-          <p:nvPr/>
+          <p:cNvSpPr/>
+          <p:nvPr>
+            <p:ph type="title"/>
+          </p:nvPr>
         </p:nvSpPr>
         <p:spPr>
           <a:xfrm>
@@ -23428,7 +23462,7 @@
               <a:buNone/>
             </a:pPr>
             <a:r>
-              <a:rPr lang="en-US" sz="2400" dirty="0">
+              <a:rPr i="0" b="0" lang="en-US" sz="2400" dirty="0">
                 <a:solidFill>
                   <a:schemeClr val="lt1"/>
                 </a:solidFill>
@@ -23451,6 +23485,9 @@
         <p:nvPicPr>
           <p:cNvPr id="121" name="Google Shape;121;p29">
             <a:extLst>
+              <a:ext uri="{C183D7F6-B498-43B3-948B-1728B52AA6E4}">
+                <adec:decorative xmlns:adec="http://schemas.microsoft.com/office/drawing/2017/decorative" val="1"/>
+              </a:ext>
               <a:ext uri="{FF2B5EF4-FFF2-40B4-BE49-F238E27FC236}">
                 <a16:creationId xmlns:a16="http://schemas.microsoft.com/office/drawing/2014/main" id="{F41376A5-18FF-9EE2-2AD5-86886DEE67F4}"/>
               </a:ext>
@@ -24145,8 +24182,10 @@
               </a:ext>
             </a:extLst>
           </p:cNvPr>
-          <p:cNvSpPr txBox="1"/>
-          <p:nvPr/>
+          <p:cNvSpPr/>
+          <p:nvPr>
+            <p:ph type="title"/>
+          </p:nvPr>
         </p:nvSpPr>
         <p:spPr>
           <a:xfrm>
@@ -24212,6 +24251,9 @@
         <p:nvPicPr>
           <p:cNvPr id="121" name="Google Shape;121;p29">
             <a:extLst>
+              <a:ext uri="{C183D7F6-B498-43B3-948B-1728B52AA6E4}">
+                <adec:decorative xmlns:adec="http://schemas.microsoft.com/office/drawing/2017/decorative" val="1"/>
+              </a:ext>
               <a:ext uri="{FF2B5EF4-FFF2-40B4-BE49-F238E27FC236}">
                 <a16:creationId xmlns:a16="http://schemas.microsoft.com/office/drawing/2014/main" id="{199AF3BA-929C-AE0B-08A8-01C74ECFB2C3}"/>
               </a:ext>
@@ -24523,8 +24565,10 @@
               </a:ext>
             </a:extLst>
           </p:cNvPr>
-          <p:cNvSpPr txBox="1"/>
-          <p:nvPr/>
+          <p:cNvSpPr/>
+          <p:nvPr>
+            <p:ph type="title"/>
+          </p:nvPr>
         </p:nvSpPr>
         <p:spPr>
           <a:xfrm>
@@ -24574,7 +24618,11 @@
               </a:rPr>
               <a:t>Bits</a:t>
             </a:r>
-            <a:endParaRPr dirty="0"/>
+            <a:endParaRPr i="0" b="0" sz="1400" dirty="0">
+              <a:solidFill>
+                <a:srgbClr val="000000"/>
+              </a:solidFill>
+            </a:endParaRPr>
           </a:p>
         </p:txBody>
       </p:sp>
@@ -24667,6 +24715,9 @@
         <p:nvPicPr>
           <p:cNvPr id="108" name="Google Shape;108;p28">
             <a:extLst>
+              <a:ext uri="{C183D7F6-B498-43B3-948B-1728B52AA6E4}">
+                <adec:decorative xmlns:adec="http://schemas.microsoft.com/office/drawing/2017/decorative" val="1"/>
+              </a:ext>
               <a:ext uri="{FF2B5EF4-FFF2-40B4-BE49-F238E27FC236}">
                 <a16:creationId xmlns:a16="http://schemas.microsoft.com/office/drawing/2014/main" id="{ECD9286F-6EB3-69F5-58DF-751E98ABD0C3}"/>
               </a:ext>
@@ -25258,8 +25309,10 @@
               </a:ext>
             </a:extLst>
           </p:cNvPr>
-          <p:cNvSpPr txBox="1"/>
-          <p:nvPr/>
+          <p:cNvSpPr/>
+          <p:nvPr>
+            <p:ph type="title"/>
+          </p:nvPr>
         </p:nvSpPr>
         <p:spPr>
           <a:xfrm>
@@ -25325,6 +25378,9 @@
         <p:nvPicPr>
           <p:cNvPr id="121" name="Google Shape;121;p29">
             <a:extLst>
+              <a:ext uri="{C183D7F6-B498-43B3-948B-1728B52AA6E4}">
+                <adec:decorative xmlns:adec="http://schemas.microsoft.com/office/drawing/2017/decorative" val="1"/>
+              </a:ext>
               <a:ext uri="{FF2B5EF4-FFF2-40B4-BE49-F238E27FC236}">
                 <a16:creationId xmlns:a16="http://schemas.microsoft.com/office/drawing/2014/main" id="{2B63B481-F43D-6BB6-C538-88D354B70D89}"/>
               </a:ext>
@@ -26200,8 +26256,10 @@
               </a:ext>
             </a:extLst>
           </p:cNvPr>
-          <p:cNvSpPr txBox="1"/>
-          <p:nvPr/>
+          <p:cNvSpPr/>
+          <p:nvPr>
+            <p:ph type="title"/>
+          </p:nvPr>
         </p:nvSpPr>
         <p:spPr>
           <a:xfrm>
@@ -26267,6 +26325,9 @@
         <p:nvPicPr>
           <p:cNvPr id="121" name="Google Shape;121;p29">
             <a:extLst>
+              <a:ext uri="{C183D7F6-B498-43B3-948B-1728B52AA6E4}">
+                <adec:decorative xmlns:adec="http://schemas.microsoft.com/office/drawing/2017/decorative" val="1"/>
+              </a:ext>
               <a:ext uri="{FF2B5EF4-FFF2-40B4-BE49-F238E27FC236}">
                 <a16:creationId xmlns:a16="http://schemas.microsoft.com/office/drawing/2014/main" id="{8BF71259-9DE7-40F5-630A-E5129BC53E3F}"/>
               </a:ext>
@@ -27589,8 +27650,10 @@
               </a:ext>
             </a:extLst>
           </p:cNvPr>
-          <p:cNvSpPr txBox="1"/>
-          <p:nvPr/>
+          <p:cNvSpPr/>
+          <p:nvPr>
+            <p:ph type="title"/>
+          </p:nvPr>
         </p:nvSpPr>
         <p:spPr>
           <a:xfrm>
@@ -27656,6 +27719,9 @@
         <p:nvPicPr>
           <p:cNvPr id="121" name="Google Shape;121;p29">
             <a:extLst>
+              <a:ext uri="{C183D7F6-B498-43B3-948B-1728B52AA6E4}">
+                <adec:decorative xmlns:adec="http://schemas.microsoft.com/office/drawing/2017/decorative" val="1"/>
+              </a:ext>
               <a:ext uri="{FF2B5EF4-FFF2-40B4-BE49-F238E27FC236}">
                 <a16:creationId xmlns:a16="http://schemas.microsoft.com/office/drawing/2014/main" id="{FF25E2F6-45BA-674E-90E9-B88C0123EA6B}"/>
               </a:ext>
@@ -27955,8 +28021,10 @@
       <p:sp>
         <p:nvSpPr>
           <p:cNvPr id="89" name="Google Shape;89;p27"/>
-          <p:cNvSpPr txBox="1"/>
-          <p:nvPr/>
+          <p:cNvSpPr/>
+          <p:nvPr>
+            <p:ph type="title"/>
+          </p:nvPr>
         </p:nvSpPr>
         <p:spPr>
           <a:xfrm>
@@ -28144,7 +28212,13 @@
       </p:grpSp>
       <p:pic>
         <p:nvPicPr>
-          <p:cNvPr id="94" name="Google Shape;94;p27"/>
+          <p:cNvPr id="94" name="Google Shape;94;p27">
+            <a:extLst>
+              <a:ext uri="{C183D7F6-B498-43B3-948B-1728B52AA6E4}">
+                <adec:decorative xmlns:adec="http://schemas.microsoft.com/office/drawing/2017/decorative" val="1"/>
+              </a:ext>
+            </a:extLst>
+          </p:cNvPr>
           <p:cNvPicPr preferRelativeResize="0"/>
           <p:nvPr/>
         </p:nvPicPr>
@@ -28884,8 +28958,10 @@
               </a:ext>
             </a:extLst>
           </p:cNvPr>
-          <p:cNvSpPr txBox="1"/>
-          <p:nvPr/>
+          <p:cNvSpPr/>
+          <p:nvPr>
+            <p:ph type="title"/>
+          </p:nvPr>
         </p:nvSpPr>
         <p:spPr>
           <a:xfrm>
@@ -28924,7 +29000,7 @@
               <a:buNone/>
             </a:pPr>
             <a:r>
-              <a:rPr lang="en-US" sz="2400" dirty="0">
+              <a:rPr i="0" b="0" lang="en-US" sz="2400" dirty="0">
                 <a:solidFill>
                   <a:schemeClr val="lt1"/>
                 </a:solidFill>
@@ -28947,6 +29023,9 @@
         <p:nvPicPr>
           <p:cNvPr id="121" name="Google Shape;121;p29">
             <a:extLst>
+              <a:ext uri="{C183D7F6-B498-43B3-948B-1728B52AA6E4}">
+                <adec:decorative xmlns:adec="http://schemas.microsoft.com/office/drawing/2017/decorative" val="1"/>
+              </a:ext>
               <a:ext uri="{FF2B5EF4-FFF2-40B4-BE49-F238E27FC236}">
                 <a16:creationId xmlns:a16="http://schemas.microsoft.com/office/drawing/2014/main" id="{281BB5D4-2A0F-5D14-FF14-E9D5E53A7135}"/>
               </a:ext>
@@ -30329,8 +30408,10 @@
               </a:ext>
             </a:extLst>
           </p:cNvPr>
-          <p:cNvSpPr txBox="1"/>
-          <p:nvPr/>
+          <p:cNvSpPr/>
+          <p:nvPr>
+            <p:ph type="title"/>
+          </p:nvPr>
         </p:nvSpPr>
         <p:spPr>
           <a:xfrm>
@@ -30380,7 +30461,11 @@
               </a:rPr>
               <a:t>Timers</a:t>
             </a:r>
-            <a:endParaRPr dirty="0"/>
+            <a:endParaRPr i="0" b="0" sz="1400" dirty="0">
+              <a:solidFill>
+                <a:srgbClr val="000000"/>
+              </a:solidFill>
+            </a:endParaRPr>
           </a:p>
         </p:txBody>
       </p:sp>
@@ -30473,6 +30558,9 @@
         <p:nvPicPr>
           <p:cNvPr id="108" name="Google Shape;108;p28">
             <a:extLst>
+              <a:ext uri="{C183D7F6-B498-43B3-948B-1728B52AA6E4}">
+                <adec:decorative xmlns:adec="http://schemas.microsoft.com/office/drawing/2017/decorative" val="1"/>
+              </a:ext>
               <a:ext uri="{FF2B5EF4-FFF2-40B4-BE49-F238E27FC236}">
                 <a16:creationId xmlns:a16="http://schemas.microsoft.com/office/drawing/2014/main" id="{C8CF2629-2730-A4EB-283A-97444685EAB0}"/>
               </a:ext>
@@ -31232,8 +31320,10 @@
               </a:ext>
             </a:extLst>
           </p:cNvPr>
-          <p:cNvSpPr txBox="1"/>
-          <p:nvPr/>
+          <p:cNvSpPr/>
+          <p:nvPr>
+            <p:ph type="title"/>
+          </p:nvPr>
         </p:nvSpPr>
         <p:spPr>
           <a:xfrm>
@@ -31299,6 +31389,9 @@
         <p:nvPicPr>
           <p:cNvPr id="121" name="Google Shape;121;p29">
             <a:extLst>
+              <a:ext uri="{C183D7F6-B498-43B3-948B-1728B52AA6E4}">
+                <adec:decorative xmlns:adec="http://schemas.microsoft.com/office/drawing/2017/decorative" val="1"/>
+              </a:ext>
               <a:ext uri="{FF2B5EF4-FFF2-40B4-BE49-F238E27FC236}">
                 <a16:creationId xmlns:a16="http://schemas.microsoft.com/office/drawing/2014/main" id="{6333CCFD-5566-247B-FBA2-4925B9AA6D88}"/>
               </a:ext>
@@ -31659,8 +31752,10 @@
               </a:ext>
             </a:extLst>
           </p:cNvPr>
-          <p:cNvSpPr txBox="1"/>
-          <p:nvPr/>
+          <p:cNvSpPr/>
+          <p:nvPr>
+            <p:ph type="title"/>
+          </p:nvPr>
         </p:nvSpPr>
         <p:spPr>
           <a:xfrm>
@@ -31726,6 +31821,9 @@
         <p:nvPicPr>
           <p:cNvPr id="121" name="Google Shape;121;p29">
             <a:extLst>
+              <a:ext uri="{C183D7F6-B498-43B3-948B-1728B52AA6E4}">
+                <adec:decorative xmlns:adec="http://schemas.microsoft.com/office/drawing/2017/decorative" val="1"/>
+              </a:ext>
               <a:ext uri="{FF2B5EF4-FFF2-40B4-BE49-F238E27FC236}">
                 <a16:creationId xmlns:a16="http://schemas.microsoft.com/office/drawing/2014/main" id="{6CD01B28-2810-7D4B-EF46-09359AE8F9E3}"/>
               </a:ext>
@@ -32407,8 +32505,10 @@
               </a:ext>
             </a:extLst>
           </p:cNvPr>
-          <p:cNvSpPr txBox="1"/>
-          <p:nvPr/>
+          <p:cNvSpPr/>
+          <p:nvPr>
+            <p:ph type="title"/>
+          </p:nvPr>
         </p:nvSpPr>
         <p:spPr>
           <a:xfrm>
@@ -32474,6 +32574,9 @@
         <p:nvPicPr>
           <p:cNvPr id="121" name="Google Shape;121;p29">
             <a:extLst>
+              <a:ext uri="{C183D7F6-B498-43B3-948B-1728B52AA6E4}">
+                <adec:decorative xmlns:adec="http://schemas.microsoft.com/office/drawing/2017/decorative" val="1"/>
+              </a:ext>
               <a:ext uri="{FF2B5EF4-FFF2-40B4-BE49-F238E27FC236}">
                 <a16:creationId xmlns:a16="http://schemas.microsoft.com/office/drawing/2014/main" id="{54BA04C2-9408-8115-FD87-8AB89A69D2E5}"/>
               </a:ext>
@@ -32729,7 +32832,7 @@
       </p:grpSp>
       <p:pic>
         <p:nvPicPr>
-          <p:cNvPr id="2" name="Online Media 1" title="CPU Timer Animation">
+          <p:cNvPr id="2" name="Online Media 1" title="CPU Timer Animation" descr="YouTube video: CPU Timer Animation (Marius Juston)">
             <a:hlinkClick r:id="" action="ppaction://media"/>
             <a:extLst>
               <a:ext uri="{FF2B5EF4-FFF2-40B4-BE49-F238E27FC236}">
@@ -33552,8 +33655,10 @@
               </a:ext>
             </a:extLst>
           </p:cNvPr>
-          <p:cNvSpPr txBox="1"/>
-          <p:nvPr/>
+          <p:cNvSpPr/>
+          <p:nvPr>
+            <p:ph type="title"/>
+          </p:nvPr>
         </p:nvSpPr>
         <p:spPr>
           <a:xfrm>
@@ -33619,6 +33724,9 @@
         <p:nvPicPr>
           <p:cNvPr id="121" name="Google Shape;121;p29">
             <a:extLst>
+              <a:ext uri="{C183D7F6-B498-43B3-948B-1728B52AA6E4}">
+                <adec:decorative xmlns:adec="http://schemas.microsoft.com/office/drawing/2017/decorative" val="1"/>
+              </a:ext>
               <a:ext uri="{FF2B5EF4-FFF2-40B4-BE49-F238E27FC236}">
                 <a16:creationId xmlns:a16="http://schemas.microsoft.com/office/drawing/2014/main" id="{94816700-3D02-C248-14E0-D7385ECBA363}"/>
               </a:ext>
@@ -33979,8 +34087,10 @@
               </a:ext>
             </a:extLst>
           </p:cNvPr>
-          <p:cNvSpPr txBox="1"/>
-          <p:nvPr/>
+          <p:cNvSpPr/>
+          <p:nvPr>
+            <p:ph type="title"/>
+          </p:nvPr>
         </p:nvSpPr>
         <p:spPr>
           <a:xfrm>
@@ -34046,6 +34156,9 @@
         <p:nvPicPr>
           <p:cNvPr id="121" name="Google Shape;121;p29">
             <a:extLst>
+              <a:ext uri="{C183D7F6-B498-43B3-948B-1728B52AA6E4}">
+                <adec:decorative xmlns:adec="http://schemas.microsoft.com/office/drawing/2017/decorative" val="1"/>
+              </a:ext>
               <a:ext uri="{FF2B5EF4-FFF2-40B4-BE49-F238E27FC236}">
                 <a16:creationId xmlns:a16="http://schemas.microsoft.com/office/drawing/2014/main" id="{1F492385-0078-432E-BA25-52EF8191B289}"/>
               </a:ext>
@@ -34807,8 +34920,10 @@
               </a:ext>
             </a:extLst>
           </p:cNvPr>
-          <p:cNvSpPr txBox="1"/>
-          <p:nvPr/>
+          <p:cNvSpPr/>
+          <p:nvPr>
+            <p:ph type="title"/>
+          </p:nvPr>
         </p:nvSpPr>
         <p:spPr>
           <a:xfrm>
@@ -34874,6 +34989,9 @@
         <p:nvPicPr>
           <p:cNvPr id="121" name="Google Shape;121;p29">
             <a:extLst>
+              <a:ext uri="{C183D7F6-B498-43B3-948B-1728B52AA6E4}">
+                <adec:decorative xmlns:adec="http://schemas.microsoft.com/office/drawing/2017/decorative" val="1"/>
+              </a:ext>
               <a:ext uri="{FF2B5EF4-FFF2-40B4-BE49-F238E27FC236}">
                 <a16:creationId xmlns:a16="http://schemas.microsoft.com/office/drawing/2014/main" id="{96E730D0-44C7-EC82-7138-C3802602FF7E}"/>
               </a:ext>
@@ -35173,8 +35291,10 @@
       <p:sp>
         <p:nvSpPr>
           <p:cNvPr id="264" name="Google Shape;264;p37"/>
-          <p:cNvSpPr txBox="1"/>
-          <p:nvPr/>
+          <p:cNvSpPr/>
+          <p:nvPr>
+            <p:ph type="title"/>
+          </p:nvPr>
         </p:nvSpPr>
         <p:spPr>
           <a:xfrm>
@@ -35195,9 +35315,19 @@
           </a:bodyPr>
           <a:lstStyle/>
           <a:p>
-            <a:pPr lvl="0" algn="ctr"/>
-            <a:r>
-              <a:rPr lang="en-US" sz="8800" b="1" dirty="0">
+            <a:pPr lvl="0" algn="ctr">
+              <a:lnSpc>
+                <a:spcPct val="100000"/>
+              </a:lnSpc>
+              <a:spcBef>
+                <a:spcPts val="0"/>
+              </a:spcBef>
+              <a:spcAft>
+                <a:spcPts val="0"/>
+              </a:spcAft>
+            </a:pPr>
+            <a:r>
+              <a:rPr i="0" lang="en-US" sz="8800" b="1" dirty="0">
                 <a:solidFill>
                   <a:schemeClr val="lt1"/>
                 </a:solidFill>
@@ -35205,7 +35335,7 @@
               <a:t>Questions</a:t>
             </a:r>
             <a:r>
-              <a:rPr lang="en-US" sz="7200" b="1" dirty="0">
+              <a:rPr i="0" lang="en-US" sz="7200" b="1" dirty="0">
                 <a:solidFill>
                   <a:schemeClr val="lt1"/>
                 </a:solidFill>
@@ -35214,9 +35344,19 @@
             </a:r>
           </a:p>
           <a:p>
-            <a:pPr lvl="0" algn="ctr"/>
-            <a:r>
-              <a:rPr lang="en-US" sz="3200" b="1" dirty="0">
+            <a:pPr lvl="0" algn="ctr">
+              <a:lnSpc>
+                <a:spcPct val="100000"/>
+              </a:lnSpc>
+              <a:spcBef>
+                <a:spcPts val="0"/>
+              </a:spcBef>
+              <a:spcAft>
+                <a:spcPts val="0"/>
+              </a:spcAft>
+            </a:pPr>
+            <a:r>
+              <a:rPr i="0" lang="en-US" sz="3200" b="1" dirty="0">
                 <a:solidFill>
                   <a:schemeClr val="lt1"/>
                 </a:solidFill>
@@ -35228,7 +35368,13 @@
       </p:sp>
       <p:pic>
         <p:nvPicPr>
-          <p:cNvPr id="265" name="Google Shape;265;p37"/>
+          <p:cNvPr id="265" name="Google Shape;265;p37">
+            <a:extLst>
+              <a:ext uri="{C183D7F6-B498-43B3-948B-1728B52AA6E4}">
+                <adec:decorative xmlns:adec="http://schemas.microsoft.com/office/drawing/2017/decorative" val="1"/>
+              </a:ext>
+            </a:extLst>
+          </p:cNvPr>
           <p:cNvPicPr preferRelativeResize="0"/>
           <p:nvPr/>
         </p:nvPicPr>
@@ -35485,9 +35631,42 @@
           <a:chExt cx="0" cy="0"/>
         </a:xfrm>
       </p:grpSpPr>
+      <p:sp>
+        <p:nvSpPr>
+          <p:cNvPr id="276" name="Title 276"/>
+          <p:cNvSpPr>
+            <a:spLocks noGrp="1"/>
+          </p:cNvSpPr>
+          <p:nvPr>
+            <p:ph type="title"/>
+          </p:nvPr>
+        </p:nvSpPr>
+        <p:spPr>
+          <a:xfrm>
+            <a:off x="0" y="-914400"/>
+            <a:ext cx="12192000" cy="685800"/>
+          </a:xfrm>
+        </p:spPr>
+        <p:txBody>
+          <a:bodyPr/>
+          <a:lstStyle/>
+          <a:p>
+            <a:r>
+              <a:rPr lang="en-US" dirty="0"/>
+              <a:t>End of Lecture 2</a:t>
+            </a:r>
+          </a:p>
+        </p:txBody>
+      </p:sp>
       <p:pic>
         <p:nvPicPr>
-          <p:cNvPr id="275" name="Google Shape;275;p38"/>
+          <p:cNvPr id="275" name="Google Shape;275;p38">
+            <a:extLst>
+              <a:ext uri="{C183D7F6-B498-43B3-948B-1728B52AA6E4}">
+                <adec:decorative xmlns:adec="http://schemas.microsoft.com/office/drawing/2017/decorative" val="1"/>
+              </a:ext>
+            </a:extLst>
+          </p:cNvPr>
           <p:cNvPicPr preferRelativeResize="0"/>
           <p:nvPr/>
         </p:nvPicPr>
@@ -36068,8 +36247,10 @@
               </a:ext>
             </a:extLst>
           </p:cNvPr>
-          <p:cNvSpPr txBox="1"/>
-          <p:nvPr/>
+          <p:cNvSpPr/>
+          <p:nvPr>
+            <p:ph type="title"/>
+          </p:nvPr>
         </p:nvSpPr>
         <p:spPr>
           <a:xfrm>
@@ -36135,6 +36316,9 @@
         <p:nvPicPr>
           <p:cNvPr id="121" name="Google Shape;121;p29">
             <a:extLst>
+              <a:ext uri="{C183D7F6-B498-43B3-948B-1728B52AA6E4}">
+                <adec:decorative xmlns:adec="http://schemas.microsoft.com/office/drawing/2017/decorative" val="1"/>
+              </a:ext>
               <a:ext uri="{FF2B5EF4-FFF2-40B4-BE49-F238E27FC236}">
                 <a16:creationId xmlns:a16="http://schemas.microsoft.com/office/drawing/2014/main" id="{28CCE647-4D9B-354D-A2E9-718CA28CD750}"/>
               </a:ext>
@@ -37011,8 +37195,10 @@
               </a:ext>
             </a:extLst>
           </p:cNvPr>
-          <p:cNvSpPr txBox="1"/>
-          <p:nvPr/>
+          <p:cNvSpPr/>
+          <p:nvPr>
+            <p:ph type="title"/>
+          </p:nvPr>
         </p:nvSpPr>
         <p:spPr>
           <a:xfrm>
@@ -37078,6 +37264,9 @@
         <p:nvPicPr>
           <p:cNvPr id="121" name="Google Shape;121;p29">
             <a:extLst>
+              <a:ext uri="{C183D7F6-B498-43B3-948B-1728B52AA6E4}">
+                <adec:decorative xmlns:adec="http://schemas.microsoft.com/office/drawing/2017/decorative" val="1"/>
+              </a:ext>
               <a:ext uri="{FF2B5EF4-FFF2-40B4-BE49-F238E27FC236}">
                 <a16:creationId xmlns:a16="http://schemas.microsoft.com/office/drawing/2014/main" id="{82D4F2AE-AF34-641F-D726-1F09D72D4F1C}"/>
               </a:ext>
@@ -37389,8 +37578,10 @@
               </a:ext>
             </a:extLst>
           </p:cNvPr>
-          <p:cNvSpPr txBox="1"/>
-          <p:nvPr/>
+          <p:cNvSpPr/>
+          <p:nvPr>
+            <p:ph type="title"/>
+          </p:nvPr>
         </p:nvSpPr>
         <p:spPr>
           <a:xfrm>
@@ -37680,6 +37871,9 @@
         <p:nvPicPr>
           <p:cNvPr id="94" name="Google Shape;94;p27">
             <a:extLst>
+              <a:ext uri="{C183D7F6-B498-43B3-948B-1728B52AA6E4}">
+                <adec:decorative xmlns:adec="http://schemas.microsoft.com/office/drawing/2017/decorative" val="1"/>
+              </a:ext>
               <a:ext uri="{FF2B5EF4-FFF2-40B4-BE49-F238E27FC236}">
                 <a16:creationId xmlns:a16="http://schemas.microsoft.com/office/drawing/2014/main" id="{442EC04A-B6B9-3EC3-CAA1-53A267F1FE2A}"/>
               </a:ext>
@@ -38313,8 +38507,10 @@
               </a:ext>
             </a:extLst>
           </p:cNvPr>
-          <p:cNvSpPr txBox="1"/>
-          <p:nvPr/>
+          <p:cNvSpPr/>
+          <p:nvPr>
+            <p:ph type="title"/>
+          </p:nvPr>
         </p:nvSpPr>
         <p:spPr>
           <a:xfrm>
@@ -38380,6 +38576,9 @@
         <p:nvPicPr>
           <p:cNvPr id="121" name="Google Shape;121;p29">
             <a:extLst>
+              <a:ext uri="{C183D7F6-B498-43B3-948B-1728B52AA6E4}">
+                <adec:decorative xmlns:adec="http://schemas.microsoft.com/office/drawing/2017/decorative" val="1"/>
+              </a:ext>
               <a:ext uri="{FF2B5EF4-FFF2-40B4-BE49-F238E27FC236}">
                 <a16:creationId xmlns:a16="http://schemas.microsoft.com/office/drawing/2014/main" id="{D4447D33-31A5-FA96-111C-05B9D666909D}"/>
               </a:ext>
@@ -38679,8 +38878,10 @@
       <p:sp>
         <p:nvSpPr>
           <p:cNvPr id="104" name="Google Shape;104;p28"/>
-          <p:cNvSpPr txBox="1"/>
-          <p:nvPr/>
+          <p:cNvSpPr/>
+          <p:nvPr>
+            <p:ph type="title"/>
+          </p:nvPr>
         </p:nvSpPr>
         <p:spPr>
           <a:xfrm>
@@ -38730,7 +38931,11 @@
               </a:rPr>
               <a:t>Registers</a:t>
             </a:r>
-            <a:endParaRPr dirty="0"/>
+            <a:endParaRPr i="0" b="0" sz="1400" dirty="0">
+              <a:solidFill>
+                <a:srgbClr val="000000"/>
+              </a:solidFill>
+            </a:endParaRPr>
           </a:p>
         </p:txBody>
       </p:sp>
@@ -38803,7 +39008,13 @@
       </p:grpSp>
       <p:pic>
         <p:nvPicPr>
-          <p:cNvPr id="108" name="Google Shape;108;p28"/>
+          <p:cNvPr id="108" name="Google Shape;108;p28">
+            <a:extLst>
+              <a:ext uri="{C183D7F6-B498-43B3-948B-1728B52AA6E4}">
+                <adec:decorative xmlns:adec="http://schemas.microsoft.com/office/drawing/2017/decorative" val="1"/>
+              </a:ext>
+            </a:extLst>
+          </p:cNvPr>
           <p:cNvPicPr preferRelativeResize="0"/>
           <p:nvPr/>
         </p:nvPicPr>
@@ -39381,8 +39592,10 @@
               </a:ext>
             </a:extLst>
           </p:cNvPr>
-          <p:cNvSpPr txBox="1"/>
-          <p:nvPr/>
+          <p:cNvSpPr/>
+          <p:nvPr>
+            <p:ph type="title"/>
+          </p:nvPr>
         </p:nvSpPr>
         <p:spPr>
           <a:xfrm>
@@ -39448,6 +39661,9 @@
         <p:nvPicPr>
           <p:cNvPr id="121" name="Google Shape;121;p29">
             <a:extLst>
+              <a:ext uri="{C183D7F6-B498-43B3-948B-1728B52AA6E4}">
+                <adec:decorative xmlns:adec="http://schemas.microsoft.com/office/drawing/2017/decorative" val="1"/>
+              </a:ext>
               <a:ext uri="{FF2B5EF4-FFF2-40B4-BE49-F238E27FC236}">
                 <a16:creationId xmlns:a16="http://schemas.microsoft.com/office/drawing/2014/main" id="{F8247348-FF7D-D515-1494-EF00C3BBBFBB}"/>
               </a:ext>
@@ -40187,8 +40403,10 @@
               </a:ext>
             </a:extLst>
           </p:cNvPr>
-          <p:cNvSpPr txBox="1"/>
-          <p:nvPr/>
+          <p:cNvSpPr/>
+          <p:nvPr>
+            <p:ph type="title"/>
+          </p:nvPr>
         </p:nvSpPr>
         <p:spPr>
           <a:xfrm>
@@ -40254,6 +40472,9 @@
         <p:nvPicPr>
           <p:cNvPr id="121" name="Google Shape;121;p29">
             <a:extLst>
+              <a:ext uri="{C183D7F6-B498-43B3-948B-1728B52AA6E4}">
+                <adec:decorative xmlns:adec="http://schemas.microsoft.com/office/drawing/2017/decorative" val="1"/>
+              </a:ext>
               <a:ext uri="{FF2B5EF4-FFF2-40B4-BE49-F238E27FC236}">
                 <a16:creationId xmlns:a16="http://schemas.microsoft.com/office/drawing/2014/main" id="{A5BF5345-B5BF-16DF-10F0-8E870569DB14}"/>
               </a:ext>

</xml_diff>